<commit_message>
Update/add files and folders
</commit_message>
<xml_diff>
--- a/Viva_Slides.pptx
+++ b/Viva_Slides.pptx
@@ -5384,48 +5384,6 @@
           </a:ln>
         </p:spPr>
       </p:sp>
-      <p:sp>
-        <p:nvSpPr>
-          <p:cNvPr id="20" name="Text 18"/>
-          <p:cNvSpPr/>
-          <p:nvPr/>
-        </p:nvSpPr>
-        <p:spPr>
-          <a:xfrm>
-            <a:off x="6611112" y="5257800"/>
-            <a:ext cx="5029200" cy="640080"/>
-          </a:xfrm>
-          <a:prstGeom prst="rect">
-            <a:avLst/>
-          </a:prstGeom>
-          <a:noFill/>
-          <a:ln/>
-        </p:spPr>
-        <p:txBody>
-          <a:bodyPr wrap="square" lIns="0" tIns="0" rIns="0" bIns="0" rtlCol="0" anchor="ctr"/>
-          <a:lstStyle/>
-          <a:p>
-            <a:pPr marL="0" indent="0">
-              <a:lnSpc>
-                <a:spcPct val="115000"/>
-              </a:lnSpc>
-              <a:buNone/>
-            </a:pPr>
-            <a:r>
-              <a:rPr lang="en-US" sz="1250" i="1" dirty="0">
-                <a:solidFill>
-                  <a:srgbClr val="C8922B"/>
-                </a:solidFill>
-                <a:latin typeface="Calibri" pitchFamily="34" charset="0"/>
-                <a:ea typeface="Calibri" pitchFamily="34" charset="-122"/>
-                <a:cs typeface="Calibri" pitchFamily="34" charset="-120"/>
-              </a:rPr>
-              <a:t>Existing literature documents accessibility features far more than it measures whether they actually help the people they target.</a:t>
-            </a:r>
-            <a:endParaRPr lang="en-US" sz="1250" dirty="0"/>
-          </a:p>
-        </p:txBody>
-      </p:sp>
       <p:pic>
         <p:nvPicPr>
           <p:cNvPr id="25" name="Picture 24">
@@ -5451,7 +5409,7 @@
         </p:blipFill>
         <p:spPr>
           <a:xfrm>
-            <a:off x="111200" y="1600200"/>
+            <a:off x="111200" y="1546597"/>
             <a:ext cx="6298744" cy="3928501"/>
           </a:xfrm>
           <a:prstGeom prst="rect">
@@ -6190,11 +6148,10 @@
           <a:bodyPr wrap="square" lIns="0" tIns="0" rIns="0" bIns="0" rtlCol="0" anchor="t"/>
           <a:lstStyle/>
           <a:p>
-            <a:pPr marL="0" indent="0">
+            <a:pPr>
               <a:lnSpc>
-                <a:spcPct val="115000"/>
+                <a:spcPct val="100000"/>
               </a:lnSpc>
-              <a:buNone/>
             </a:pPr>
             <a:r>
               <a:rPr lang="en-US" sz="1500" b="1" dirty="0">
@@ -6216,7 +6173,7 @@
                 <a:ea typeface="Calibri" pitchFamily="34" charset="-122"/>
                 <a:cs typeface="Calibri" pitchFamily="34" charset="-120"/>
               </a:rPr>
-              <a:t>chatbots and voice </a:t>
+              <a:t>chatbots and voice navigation excluded, since the evidence for their accessibility benefit is largely unevaluated in the </a:t>
             </a:r>
             <a:r>
               <a:rPr lang="en-US" sz="1350">
@@ -6227,20 +6184,39 @@
                 <a:ea typeface="Calibri" pitchFamily="34" charset="-122"/>
                 <a:cs typeface="Calibri" pitchFamily="34" charset="-120"/>
               </a:rPr>
-              <a:t>navigation excluded</a:t>
+              <a:t>current </a:t>
+            </a:r>
+            <a:r>
+              <a:rPr lang="en-US" sz="1350">
+                <a:solidFill>
+                  <a:srgbClr val="1A1A2E"/>
+                </a:solidFill>
+                <a:ea typeface="Calibri" pitchFamily="34" charset="-122"/>
+                <a:cs typeface="Calibri" pitchFamily="34" charset="-120"/>
+              </a:rPr>
+              <a:t>literature (</a:t>
             </a:r>
             <a:r>
               <a:rPr lang="en-US" sz="1350" dirty="0">
                 <a:solidFill>
                   <a:srgbClr val="1A1A2E"/>
                 </a:solidFill>
-                <a:latin typeface="Calibri" pitchFamily="34" charset="0"/>
                 <a:ea typeface="Calibri" pitchFamily="34" charset="-122"/>
                 <a:cs typeface="Calibri" pitchFamily="34" charset="-120"/>
               </a:rPr>
-              <a:t>, since the evidence for their accessibility benefit is largely unevaluated in the current literature</a:t>
+              <a:t>growing body </a:t>
             </a:r>
-            <a:endParaRPr lang="en-US" sz="1500" dirty="0"/>
+            <a:r>
+              <a:rPr lang="en-US" sz="1350">
+                <a:solidFill>
+                  <a:srgbClr val="1A1A2E"/>
+                </a:solidFill>
+                <a:ea typeface="Calibri" pitchFamily="34" charset="-122"/>
+                <a:cs typeface="Calibri" pitchFamily="34" charset="-120"/>
+              </a:rPr>
+              <a:t>of research)</a:t>
+            </a:r>
+            <a:endParaRPr lang="en-US" sz="1350" dirty="0"/>
           </a:p>
         </p:txBody>
       </p:sp>

</xml_diff>